<commit_message>
docs: opcao (c) para sitios de afericao, emendas propostas, preditores otimizados, leitura de Renard/Waltrick e prompt do executor v2
- prompt do executor: blocos N06 (emendas aceitas) e N07 (CAR e perimetros reais fora do git)
- anexos: avaliador com grade pre-registrada de p, INCONCLUSIVA_MARGEM, sensibilidades e linha de base por Celula_ID (38 testes)
- manual e apresentacao atualizados (verificacao de R e LS)

Co-Authored-By: Claude Sonnet 5.5 <noreply@anthropic.com>
Claude-Session: https://claude.ai/code/session_01QBooVKGGKQGrenTtP2atqx
</commit_message>
<xml_diff>
--- a/docs/Apresentacao_Pesquisa_SAREL_2026-10-06.pptx
+++ b/docs/Apresentacao_Pesquisa_SAREL_2026-10-06.pptx
@@ -1726,7 +1726,7 @@
           <a:p>
             <a:r>
               <a:rPr lang="en-US" dirty="0"/>
-              <a:t>Piso 0,40 e margem 0,10 são intermediários entre 0,15/0,50 (estrito) e 0,05 (permissivo). A AUC ≥ 0,70 (regra de bolso atribuída a Hosmer; Lemeshow, não conferida na fonte) e ΔAUC ≥ 0,05 são secundárias. Lacuna detectada: piso atingido, ρ_XGB ≥ ρ_RUSLE, mas margem &lt; 0,10 não tem desfecho definido em D25; o código devolve NAO_PREVISTO_EM_D25 e o pesquisador deve decidir. Também não está dito se as secundárias condicionam o desfecho.</a:t>
+              <a:t>Piso 0,40 e margem 0,10 são intermediários entre 0,15/0,50 (estrito) e 0,05 (permissivo). A AUC ≥ 0,70 (regra de bolso atribuída a Hosmer; Lemeshow, não conferida na fonte) e ΔAUC ≥ 0,05 são secundárias. A lacuna detectada (piso atingido, ρ_XGB ≥ ρ_RUSLE, margem &lt; 0,10) foi fechada por emenda aceita em 06/10/2026: INCONCLUSIVA_MARGEM; as secundárias não condicionam o desfecho.</a:t>
             </a:r>
             <a:endParaRPr lang="en-US" dirty="0"/>
           </a:p>
@@ -2254,7 +2254,7 @@
           <a:p>
             <a:r>
               <a:rPr lang="en-US" dirty="0"/>
-              <a:t>Medições de 06/10/2026 no commit 4834cf0: typecheck exit 0; lint 2 warnings; vitest 57 arquivos/435 testes, 6 falham (dados locais); next build falha por import de node:crypto/node:child_process em componente de cliente; next dev responde HTTP 500. A auditoria (A01–A54) gerou o prompt de correção (30 blocos) e o prompt do executor, com anexos de código de referência testados (35 testes Python).</a:t>
+              <a:t>Medições de 06/10/2026 no commit 4834cf0: typecheck exit 0; lint 2 warnings; vitest 57 arquivos/435 testes, 6 falham (dados locais); next build falha por import de node:crypto/node:child_process em componente de cliente; next dev responde HTTP 500. A auditoria (A01–A54) gerou o prompt de correção (30 blocos) e o prompt do executor, com anexos de código de referência testados (38 testes Python).</a:t>
             </a:r>
             <a:endParaRPr lang="en-US" dirty="0"/>
           </a:p>
@@ -4374,7 +4374,7 @@
                   <a:schemeClr val="tx1"/>
                 </a:solidFill>
               </a:rPr>
-              <a:t>GLM com ligação log, p = 1,5 (proposta), penalização L2 (FRIEDMAN; HASTIE; TIBSHIRANI, 2010), α escolhido por validação agrupada por polígono; imputação só com a mediana do treino da dobra, mais indicador de ausência.</a:t>
+              <a:t>GLM com ligação log, p ∈ {1,2; 1,5; 1,8} escolhido no treino, penalização L2 (FRIEDMAN; HASTIE; TIBSHIRANI, 2010), α escolhido por validação agrupada por polígono; imputação só com a mediana do treino da dobra, mais indicador de ausência.</a:t>
             </a:r>
             <a:endParaRPr lang="en-US" sz="1300" dirty="0"/>
           </a:p>
@@ -4741,7 +4741,7 @@
                   <a:schemeClr val="tx1"/>
                 </a:solidFill>
               </a:rPr>
-              <a:t>p = 1,5 é proposta (P10), não decisão; qualquer ajuste de p ocorre só dentro do treino.</a:t>
+              <a:t>O expoente p é proposta (P10): escolhido por validação interna dentro da grade pré-registrada {1,2; 1,5; 1,8}.</a:t>
             </a:r>
             <a:endParaRPr lang="en-US" sz="1500" dirty="0"/>
           </a:p>
@@ -6886,7 +6886,7 @@
                   <a:schemeClr val="bg1"/>
                 </a:solidFill>
               </a:rPr>
-              <a:t>Lacuna de D25 (pesquisador decide)</a:t>
+              <a:t>INCONCLUSIVA por margem (emenda)</a:t>
             </a:r>
             <a:endParaRPr lang="en-US" sz="1300" dirty="0"/>
           </a:p>
@@ -6991,7 +6991,7 @@
                   <a:schemeClr val="tx1"/>
                 </a:solidFill>
               </a:rPr>
-              <a:t>4º desfecho, independente: se a Tweedie penalizada empatar com o XGBoost ou vencê-lo dentro do intervalo, H2 é refutada. AUC ≥ 0,70 e ΔAUC ≥ 0,05 são secundárias (HANLEY; MCNEIL, 1982).</a:t>
+              <a:t>4º desfecho: se a Tweedie penalizada empatar com o XGBoost ou vencê-lo no intervalo, H2 é refutada. AUC (≥ 0,70; Δ ≥ 0,05) só reportada (HANLEY; MCNEIL, 1982).</a:t>
             </a:r>
             <a:endParaRPr lang="en-US" sz="1400" dirty="0"/>
           </a:p>
@@ -9380,7 +9380,7 @@
                   <a:schemeClr val="tx1"/>
                 </a:solidFill>
               </a:rPr>
-              <a:t>R é sucedâneo regional do EI30 sobre CHIRPS diário; coeficientes ainda não conferidos (D13).</a:t>
+              <a:t>R é sucedâneo regional do EI30 sobre CHIRPS diário; coeficientes de Rufino et al. (1993) não obtidos (D13); LS: Renard conferido, Desmet; Govers não.</a:t>
             </a:r>
             <a:endParaRPr lang="en-US" sz="1500" dirty="0"/>
           </a:p>
@@ -9917,7 +9917,7 @@
                 <a:ea typeface="Cambria" pitchFamily="34" charset="-122"/>
                 <a:cs typeface="Cambria" pitchFamily="34" charset="-120"/>
               </a:rPr>
-              <a:t>35</a:t>
+              <a:t>38</a:t>
             </a:r>
             <a:endParaRPr lang="en-US" sz="3600" dirty="0"/>
           </a:p>
@@ -11818,7 +11818,7 @@
                   <a:schemeClr val="tx1"/>
                 </a:solidFill>
               </a:rPr>
-              <a:t>WALTRICK, P. C. et al. Estimativa da erosividade de chuvas no estado do Paraná pelo método da pluviometria. </a:t>
+              <a:t>WALTRICK, P. C. et al. Estimativa da erosividade de chuvas no estado do Paraná pelo método da pluviometria: atualização com dados de 1986 a 2008. </a:t>
             </a:r>
             <a:pPr indent="0" marL="0">
               <a:spcAft>
@@ -11846,7 +11846,7 @@
                   <a:schemeClr val="tx1"/>
                 </a:solidFill>
               </a:rPr>
-              <a:t>, v. 39, n. 1, p. 256-267, 2015.</a:t>
+              <a:t>, v. 39, n. 1, p. 256-267, 2015. DOI: 10.1590/01000683rbcs20150147.</a:t>
             </a:r>
             <a:endParaRPr lang="en-US" sz="1100" dirty="0"/>
           </a:p>
@@ -16449,7 +16449,7 @@
                   <a:schemeClr val="tx2"/>
                 </a:solidFill>
               </a:rPr>
-              <a:t>C: (DURIGON et al., 2014); LS: (DESMET; GOVERS, 1996); A: (RENARD et al., 1997). EI30 verdadeiro não é obtenível de dado diário: a equação regional é sucedâneo (D13) e seus coeficientes ainda NÃO foram conferidos.</a:t>
+              <a:t>C: (DURIGON et al., 2014); LS: (DESMET; GOVERS, 1996); A: (RENARD et al., 1997). EI30 verdadeiro não é obtenível de dado diário: a equação regional é sucedâneo (D13) e os coeficientes de Rufino et al. (1993) ainda NÃO foram conferidos.</a:t>
             </a:r>
             <a:endParaRPr lang="en-US" sz="1000" dirty="0"/>
           </a:p>

</xml_diff>

<commit_message>
docs: Rufino et al. (1993) lido no PDF; coeficientes da Regiao 1, fator 10 de unidade inferido, Quadro 1 de Waltrick transcrito; bloco N09 (Fator R) e achado A57
Co-Authored-By: Claude Sonnet 5.5 <noreply@anthropic.com>
Claude-Session: https://claude.ai/code/session_01QBooVKGGKQGrenTtP2atqx
</commit_message>
<xml_diff>
--- a/docs/Apresentacao_Pesquisa_SAREL_2026-10-06.pptx
+++ b/docs/Apresentacao_Pesquisa_SAREL_2026-10-06.pptx
@@ -9380,7 +9380,7 @@
                   <a:schemeClr val="tx1"/>
                 </a:solidFill>
               </a:rPr>
-              <a:t>R é sucedâneo regional do EI30 sobre CHIRPS diário; coeficientes de Rufino et al. (1993) não obtidos (D13); LS: equações de Renard e Desmet; Govers conferidas.</a:t>
+              <a:t>R é sucedâneo regional do EI30 sobre CHIRPS diário; R: coeficientes de Rufino (1993) lidos, mas o fator 10 de unidade é inferido (D13); LS: equações conferidas.</a:t>
             </a:r>
             <a:endParaRPr lang="en-US" sz="1500" dirty="0"/>
           </a:p>
@@ -16449,7 +16449,7 @@
                   <a:schemeClr val="tx2"/>
                 </a:solidFill>
               </a:rPr>
-              <a:t>C: (DURIGON et al., 2014); LS: (DESMET; GOVERS, 1996); A: (RENARD et al., 1997). EI30 verdadeiro não é obtenível de dado diário: a equação regional é sucedâneo (D13) e os coeficientes de Rufino et al. (1993) ainda NÃO foram conferidos.</a:t>
+              <a:t>C: (DURIGON et al., 2014); LS: (DESMET; GOVERS, 1996); A: (RENARD et al., 1997). R: sucedâneo regional do EI30 (D13); fator 10 de unidade (Rufino et al., 1993) inferido.</a:t>
             </a:r>
             <a:endParaRPr lang="en-US" sz="1000" dirty="0"/>
           </a:p>

</xml_diff>

<commit_message>
docs: apresentacao e manual com fator de unidade 9,81 reproduzido em pluviometros IAT
Co-Authored-By: Claude Sonnet 5.5 <noreply@anthropic.com>
Claude-Session: https://claude.ai/code/session_01QBooVKGGKQGrenTtP2atqx
</commit_message>
<xml_diff>
--- a/docs/Apresentacao_Pesquisa_SAREL_2026-10-06.pptx
+++ b/docs/Apresentacao_Pesquisa_SAREL_2026-10-06.pptx
@@ -9380,7 +9380,7 @@
                   <a:schemeClr val="tx1"/>
                 </a:solidFill>
               </a:rPr>
-              <a:t>R é sucedâneo regional do EI30 sobre CHIRPS diário; R: coeficientes de Rufino (1993) lidos, mas o fator 10 de unidade é inferido (D13); LS: equações conferidas.</a:t>
+              <a:t>R é sucedâneo regional do EI30 sobre CHIRPS diário; R: coeficientes de Rufino (1993) lidos, e o fator de unidade 9,81 reproduz o R de Waltrick em 12 estações do IAT, a &lt;0,3% (D13; origem física a confirmar); LS: equações conferidas.</a:t>
             </a:r>
             <a:endParaRPr lang="en-US" sz="1500" dirty="0"/>
           </a:p>
@@ -16449,7 +16449,7 @@
                   <a:schemeClr val="tx2"/>
                 </a:solidFill>
               </a:rPr>
-              <a:t>C: (DURIGON et al., 2014); LS: (DESMET; GOVERS, 1996); A: (RENARD et al., 1997). R: sucedâneo regional do EI30 (D13); fator 10 de unidade (Rufino et al., 1993) inferido.</a:t>
+              <a:t>C: (DURIGON et al., 2014); LS: (DESMET; GOVERS, 1996); A: (RENARD et al., 1997). R: sucedâneo regional do EI30 (D13); fator de unidade 9,81 reproduzido em pluviômetros do IAT (origem física a confirmar).</a:t>
             </a:r>
             <a:endParaRPr lang="en-US" sz="1000" dirty="0"/>
           </a:p>

</xml_diff>

<commit_message>
docs: revisao global de 09/10 (62 achados), prompt do executor v3 (N10-N17, DP-1..DP-19), tolerancia de R fixada em +-10%, fator 9,81 (Waltrick 2010), anexos corrigidos (49 testes), apresentacao e manual atualizados
Co-Authored-By: Claude Sonnet 5.5 <noreply@anthropic.com>
Claude-Session: https://claude.ai/code/session_01QBooVKGGKQGrenTtP2atqx
</commit_message>
<xml_diff>
--- a/docs/Apresentacao_Pesquisa_SAREL_2026-10-06.pptx
+++ b/docs/Apresentacao_Pesquisa_SAREL_2026-10-06.pptx
@@ -30,9 +30,10 @@
     <p:sldId id="278" r:id="rId24"/>
     <p:sldId id="279" r:id="rId25"/>
     <p:sldId id="280" r:id="rId26"/>
+    <p:sldId id="281" r:id="rId27"/>
   </p:sldIdLst>
   <p:notesMasterIdLst>
-    <p:notesMasterId r:id="rId27"/>
+    <p:notesMasterId r:id="rId28"/>
   </p:notesMasterIdLst>
   <p:sldSz cx="9144000" cy="5143500"/>
   <p:notesSz cx="5143500" cy="9144000"/>
@@ -2542,6 +2543,94 @@
             <a:fld id="{F7021451-1387-4CA6-816F-3879F97B5CBC}" type="slidenum">
               <a:rPr lang="en-US"/>
               <a:t>25</a:t>
+            </a:fld>
+            <a:endParaRPr lang="en-US"/>
+          </a:p>
+        </p:txBody>
+      </p:sp>
+    </p:spTree>
+    <p:extLst>
+      <p:ext uri="{BB962C8B-B14F-4D97-AF65-F5344CB8AC3E}">
+        <p14:creationId xmlns:p14="http://schemas.microsoft.com/office/powerpoint/2010/main" val="1024086991"/>
+      </p:ext>
+    </p:extLst>
+  </p:cSld>
+  <p:clrMapOvr>
+    <a:masterClrMapping/>
+  </p:clrMapOvr>
+</p:notes>
+</file>
+
+<file path=ppt/notesSlides/notesSlide26.xml><?xml version="1.0" encoding="utf-8"?>
+<p:notes xmlns:a="http://schemas.openxmlformats.org/drawingml/2006/main" xmlns:r="http://schemas.openxmlformats.org/officeDocument/2006/relationships" xmlns:p="http://schemas.openxmlformats.org/presentationml/2006/main">
+  <p:cSld>
+    <p:spTree>
+      <p:nvGrpSpPr>
+        <p:cNvPr id="1" name=""/>
+        <p:cNvGrpSpPr/>
+        <p:nvPr/>
+      </p:nvGrpSpPr>
+      <p:grpSpPr>
+        <a:xfrm>
+          <a:off x="0" y="0"/>
+          <a:ext cx="0" cy="0"/>
+          <a:chOff x="0" y="0"/>
+          <a:chExt cx="0" cy="0"/>
+        </a:xfrm>
+      </p:grpSpPr>
+      <p:sp>
+        <p:nvSpPr>
+          <p:cNvPr id="2" name="Slide Image Placeholder 1"/>
+          <p:cNvSpPr>
+            <a:spLocks noGrp="1" noRot="1" noChangeAspect="1"/>
+          </p:cNvSpPr>
+          <p:nvPr>
+            <p:ph type="sldImg"/>
+          </p:nvPr>
+        </p:nvSpPr>
+        <p:spPr/>
+      </p:sp>
+      <p:sp>
+        <p:nvSpPr>
+          <p:cNvPr id="3" name="Notes Placeholder 2"/>
+          <p:cNvSpPr>
+            <a:spLocks noGrp="1"/>
+          </p:cNvSpPr>
+          <p:nvPr>
+            <p:ph type="body" idx="1"/>
+          </p:nvPr>
+        </p:nvSpPr>
+        <p:spPr/>
+        <p:txBody>
+          <a:bodyPr/>
+          <a:lstStyle/>
+          <a:p>
+            <a:r>
+              <a:rPr lang="en-US" dirty="0"/>
+              <a:t>Verificação: cada referência foi conferida por resultado de busca em 06/10/2026; os campos não confirmados estão listados no Manual de Procedimentos, Apêndice C. Links não foram abertos (acesso bloqueado nesta sessão).</a:t>
+            </a:r>
+            <a:endParaRPr lang="en-US" dirty="0"/>
+          </a:p>
+        </p:txBody>
+      </p:sp>
+      <p:sp>
+        <p:nvSpPr>
+          <p:cNvPr id="4" name="Slide Number Placeholder 3"/>
+          <p:cNvSpPr>
+            <a:spLocks noGrp="1"/>
+          </p:cNvSpPr>
+          <p:nvPr>
+            <p:ph type="sldNum" sz="quarter" idx="10"/>
+          </p:nvPr>
+        </p:nvSpPr>
+        <p:spPr/>
+        <p:txBody>
+          <a:bodyPr/>
+          <a:lstStyle/>
+          <a:p>
+            <a:fld id="{F7021451-1387-4CA6-816F-3879F97B5CBC}" type="slidenum">
+              <a:rPr lang="en-US"/>
+              <a:t>26</a:t>
             </a:fld>
             <a:endParaRPr lang="en-US"/>
           </a:p>
@@ -9380,7 +9469,7 @@
                   <a:schemeClr val="tx1"/>
                 </a:solidFill>
               </a:rPr>
-              <a:t>R é sucedâneo regional do EI30 sobre CHIRPS diário; R: coeficientes de Rufino (1993) lidos, e o fator de unidade 9,81 reproduz o R de Waltrick em 12 estações do IAT, a &lt;0,3% (D13; origem física a confirmar); LS: equações conferidas.</a:t>
+              <a:t>R é sucedâneo regional do EI30 sobre CHIRPS diário; R: coeficientes de Rufino (1993) lidos, e o fator de unidade 9,81 (SI; (WALTRICK, 2010)) reproduz o R do Quadro 1 em 12 estações do IAT, a ±0,004%; tolerância de R por CHIRPS fixada em ±10% (D13); LS: equações conferidas.</a:t>
             </a:r>
             <a:endParaRPr lang="en-US" sz="1500" dirty="0"/>
           </a:p>
@@ -10562,108 +10651,6 @@
               </a:rPr>
               <a:t>, v. 15, n. 4, p. 267-280, 2005. DOI: 10.1007/s11222-005-4070-y.</a:t>
             </a:r>
-            <a:endParaRPr lang="en-US" sz="1100" dirty="0"/>
-          </a:p>
-          <a:p>
-            <a:pPr indent="0" marL="0">
-              <a:spcAft>
-                <a:spcPts val="400"/>
-              </a:spcAft>
-              <a:buNone/>
-            </a:pPr>
-            <a:pPr indent="0" marL="0">
-              <a:spcAft>
-                <a:spcPts val="400"/>
-              </a:spcAft>
-              <a:buNone/>
-            </a:pPr>
-            <a:r>
-              <a:rPr lang="en-US" sz="1100" dirty="0">
-                <a:solidFill>
-                  <a:schemeClr val="tx1"/>
-                </a:solidFill>
-              </a:rPr>
-              <a:t>DURIGON, V. L. et al. NDVI time series for monitoring RUSLE cover management factor in a tropical watershed. </a:t>
-            </a:r>
-            <a:pPr indent="0" marL="0">
-              <a:spcAft>
-                <a:spcPts val="400"/>
-              </a:spcAft>
-              <a:buNone/>
-            </a:pPr>
-            <a:r>
-              <a:rPr lang="en-US" sz="1100" b="1" dirty="0">
-                <a:solidFill>
-                  <a:schemeClr val="tx1"/>
-                </a:solidFill>
-              </a:rPr>
-              <a:t>International Journal of Remote Sensing</a:t>
-            </a:r>
-            <a:pPr indent="0" marL="0">
-              <a:spcAft>
-                <a:spcPts val="400"/>
-              </a:spcAft>
-              <a:buNone/>
-            </a:pPr>
-            <a:r>
-              <a:rPr lang="en-US" sz="1100" dirty="0">
-                <a:solidFill>
-                  <a:schemeClr val="tx1"/>
-                </a:solidFill>
-              </a:rPr>
-              <a:t>, v. 35, n. 2, p. 441-453, 2014.</a:t>
-            </a:r>
-            <a:endParaRPr lang="en-US" sz="1100" dirty="0"/>
-          </a:p>
-          <a:p>
-            <a:pPr indent="0" marL="0">
-              <a:spcAft>
-                <a:spcPts val="400"/>
-              </a:spcAft>
-              <a:buNone/>
-            </a:pPr>
-            <a:pPr indent="0" marL="0">
-              <a:spcAft>
-                <a:spcPts val="400"/>
-              </a:spcAft>
-              <a:buNone/>
-            </a:pPr>
-            <a:r>
-              <a:rPr lang="en-US" sz="1100" dirty="0">
-                <a:solidFill>
-                  <a:schemeClr val="tx1"/>
-                </a:solidFill>
-              </a:rPr>
-              <a:t>EFRON, B. Bootstrap methods: another look at the jackknife. </a:t>
-            </a:r>
-            <a:pPr indent="0" marL="0">
-              <a:spcAft>
-                <a:spcPts val="400"/>
-              </a:spcAft>
-              <a:buNone/>
-            </a:pPr>
-            <a:r>
-              <a:rPr lang="en-US" sz="1100" b="1" dirty="0">
-                <a:solidFill>
-                  <a:schemeClr val="tx1"/>
-                </a:solidFill>
-              </a:rPr>
-              <a:t>The Annals of Statistics</a:t>
-            </a:r>
-            <a:pPr indent="0" marL="0">
-              <a:spcAft>
-                <a:spcPts val="400"/>
-              </a:spcAft>
-              <a:buNone/>
-            </a:pPr>
-            <a:r>
-              <a:rPr lang="en-US" sz="1100" dirty="0">
-                <a:solidFill>
-                  <a:schemeClr val="tx1"/>
-                </a:solidFill>
-              </a:rPr>
-              <a:t>, v. 7, n. 1, p. 1-26, 1979. DOI: 10.1214/aos/1176344552.</a:t>
-            </a:r>
             <a:pPr indent="0" marL="0">
               <a:spcAft>
                 <a:spcPts val="400"/>
@@ -10818,7 +10805,7 @@
                   <a:schemeClr val="tx1"/>
                 </a:solidFill>
               </a:rPr>
-              <a:t>EUROPEAN SPACE AGENCY. </a:t>
+              <a:t>DURIGON, V. L. et al. NDVI time series for monitoring RUSLE cover management factor in a tropical watershed. </a:t>
             </a:r>
             <a:pPr indent="0" marL="0">
               <a:spcAft>
@@ -10832,7 +10819,7 @@
                   <a:schemeClr val="tx1"/>
                 </a:solidFill>
               </a:rPr>
-              <a:t>Copernicus Global Digital Elevation Model</a:t>
+              <a:t>International Journal of Remote Sensing</a:t>
             </a:r>
             <a:pPr indent="0" marL="0">
               <a:spcAft>
@@ -10846,7 +10833,7 @@
                   <a:schemeClr val="tx1"/>
                 </a:solidFill>
               </a:rPr>
-              <a:t>. [S. l.]: ESA, [s. d.]. DOI: 10.5270/ESA-c5d3d65.</a:t>
+              <a:t>, v. 35, n. 2, p. 441-453, 2014.</a:t>
             </a:r>
             <a:endParaRPr lang="en-US" sz="1100" dirty="0"/>
           </a:p>
@@ -10869,7 +10856,7 @@
                   <a:schemeClr val="tx1"/>
                 </a:solidFill>
               </a:rPr>
-              <a:t>FRIEDMAN, J.; HASTIE, T.; TIBSHIRANI, R. Regularization paths for generalized linear models via coordinate descent. </a:t>
+              <a:t>EFRON, B. Bootstrap methods: another look at the jackknife. </a:t>
             </a:r>
             <a:pPr indent="0" marL="0">
               <a:spcAft>
@@ -10883,7 +10870,7 @@
                   <a:schemeClr val="tx1"/>
                 </a:solidFill>
               </a:rPr>
-              <a:t>Journal of Statistical Software</a:t>
+              <a:t>The Annals of Statistics</a:t>
             </a:r>
             <a:pPr indent="0" marL="0">
               <a:spcAft>
@@ -10897,7 +10884,7 @@
                   <a:schemeClr val="tx1"/>
                 </a:solidFill>
               </a:rPr>
-              <a:t>, v. 33, n. 1, p. 1-22, 2010.</a:t>
+              <a:t>, v. 7, n. 1, p. 1-26, 1979. DOI: 10.1214/aos/1176344552.</a:t>
             </a:r>
             <a:endParaRPr lang="en-US" sz="1100" dirty="0"/>
           </a:p>
@@ -10920,7 +10907,7 @@
                   <a:schemeClr val="tx1"/>
                 </a:solidFill>
               </a:rPr>
-              <a:t>FUNK, C. et al. The climate hazards infrared precipitation with stations: a new environmental record for monitoring extremes. </a:t>
+              <a:t>EUROPEAN SPACE AGENCY. </a:t>
             </a:r>
             <a:pPr indent="0" marL="0">
               <a:spcAft>
@@ -10934,7 +10921,7 @@
                   <a:schemeClr val="tx1"/>
                 </a:solidFill>
               </a:rPr>
-              <a:t>Scientific Data</a:t>
+              <a:t>Copernicus Global Digital Elevation Model</a:t>
             </a:r>
             <a:pPr indent="0" marL="0">
               <a:spcAft>
@@ -10948,7 +10935,7 @@
                   <a:schemeClr val="tx1"/>
                 </a:solidFill>
               </a:rPr>
-              <a:t>, v. 2, art. 150066, 2015. DOI: 10.1038/sdata.2015.66.</a:t>
+              <a:t>. [S. l.]: ESA, [s. d.]. DOI: 10.5270/ESA-c5d3d65.</a:t>
             </a:r>
             <a:endParaRPr lang="en-US" sz="1100" dirty="0"/>
           </a:p>
@@ -10971,7 +10958,7 @@
                   <a:schemeClr val="tx1"/>
                 </a:solidFill>
               </a:rPr>
-              <a:t>GORELICK, N. et al. Google Earth Engine: planetary-scale geospatial analysis for everyone. </a:t>
+              <a:t>FRIEDMAN, J.; HASTIE, T.; TIBSHIRANI, R. Regularization paths for generalized linear models via coordinate descent. </a:t>
             </a:r>
             <a:pPr indent="0" marL="0">
               <a:spcAft>
@@ -10985,7 +10972,7 @@
                   <a:schemeClr val="tx1"/>
                 </a:solidFill>
               </a:rPr>
-              <a:t>Remote Sensing of Environment</a:t>
+              <a:t>Journal of Statistical Software</a:t>
             </a:r>
             <a:pPr indent="0" marL="0">
               <a:spcAft>
@@ -10999,7 +10986,7 @@
                   <a:schemeClr val="tx1"/>
                 </a:solidFill>
               </a:rPr>
-              <a:t>, v. 202, p. 18-27, 2017.</a:t>
+              <a:t>, v. 33, n. 1, p. 1-22, 2010.</a:t>
             </a:r>
             <a:endParaRPr lang="en-US" sz="1100" dirty="0"/>
           </a:p>
@@ -11022,7 +11009,7 @@
                   <a:schemeClr val="tx1"/>
                 </a:solidFill>
               </a:rPr>
-              <a:t>HANLEY, J. A.; MCNEIL, B. J. The meaning and use of the area under a receiver operating characteristic (ROC) curve. </a:t>
+              <a:t>FUNK, C. et al. The climate hazards infrared precipitation with stations: a new environmental record for monitoring extremes. </a:t>
             </a:r>
             <a:pPr indent="0" marL="0">
               <a:spcAft>
@@ -11036,7 +11023,7 @@
                   <a:schemeClr val="tx1"/>
                 </a:solidFill>
               </a:rPr>
-              <a:t>Radiology</a:t>
+              <a:t>Scientific Data</a:t>
             </a:r>
             <a:pPr indent="0" marL="0">
               <a:spcAft>
@@ -11050,7 +11037,7 @@
                   <a:schemeClr val="tx1"/>
                 </a:solidFill>
               </a:rPr>
-              <a:t>, v. 143, n. 1, p. 29-36, 1982.</a:t>
+              <a:t>, v. 2, art. 150066, 2015. DOI: 10.1038/sdata.2015.66.</a:t>
             </a:r>
             <a:endParaRPr lang="en-US" sz="1100" dirty="0"/>
           </a:p>
@@ -11073,7 +11060,7 @@
                   <a:schemeClr val="tx1"/>
                 </a:solidFill>
               </a:rPr>
-              <a:t>HORVITZ, D. G.; THOMPSON, D. J. A generalization of sampling without replacement from a finite universe. </a:t>
+              <a:t>GORELICK, N. et al. Google Earth Engine: planetary-scale geospatial analysis for everyone. </a:t>
             </a:r>
             <a:pPr indent="0" marL="0">
               <a:spcAft>
@@ -11087,7 +11074,7 @@
                   <a:schemeClr val="tx1"/>
                 </a:solidFill>
               </a:rPr>
-              <a:t>Journal of the American Statistical Association</a:t>
+              <a:t>Remote Sensing of Environment</a:t>
             </a:r>
             <a:pPr indent="0" marL="0">
               <a:spcAft>
@@ -11101,7 +11088,7 @@
                   <a:schemeClr val="tx1"/>
                 </a:solidFill>
               </a:rPr>
-              <a:t>, v. 47, p. 663-685, 1952.</a:t>
+              <a:t>, v. 202, p. 18-27, 2017.</a:t>
             </a:r>
             <a:endParaRPr lang="en-US" sz="1100" dirty="0"/>
           </a:p>
@@ -11124,7 +11111,7 @@
                   <a:schemeClr val="tx1"/>
                 </a:solidFill>
               </a:rPr>
-              <a:t>KAUFMAN, S. et al. Leakage in data mining: formulation, detection, and avoidance. </a:t>
+              <a:t>HANLEY, J. A.; MCNEIL, B. J. The meaning and use of the area under a receiver operating characteristic (ROC) curve. </a:t>
             </a:r>
             <a:pPr indent="0" marL="0">
               <a:spcAft>
@@ -11138,7 +11125,7 @@
                   <a:schemeClr val="tx1"/>
                 </a:solidFill>
               </a:rPr>
-              <a:t>ACM Transactions on Knowledge Discovery from Data</a:t>
+              <a:t>Radiology</a:t>
             </a:r>
             <a:pPr indent="0" marL="0">
               <a:spcAft>
@@ -11152,7 +11139,7 @@
                   <a:schemeClr val="tx1"/>
                 </a:solidFill>
               </a:rPr>
-              <a:t>, v. 6, n. 4, art. 15, 2012.</a:t>
+              <a:t>, v. 143, n. 1, p. 29-36, 1982.</a:t>
             </a:r>
             <a:endParaRPr lang="en-US" sz="1100" dirty="0"/>
           </a:p>
@@ -11175,7 +11162,7 @@
                   <a:schemeClr val="tx1"/>
                 </a:solidFill>
               </a:rPr>
-              <a:t>KING, G.; ZENG, L. Logistic regression in rare events data. </a:t>
+              <a:t>HORVITZ, D. G.; THOMPSON, D. J. A generalization of sampling without replacement from a finite universe. </a:t>
             </a:r>
             <a:pPr indent="0" marL="0">
               <a:spcAft>
@@ -11189,7 +11176,7 @@
                   <a:schemeClr val="tx1"/>
                 </a:solidFill>
               </a:rPr>
-              <a:t>Political Analysis</a:t>
+              <a:t>Journal of the American Statistical Association</a:t>
             </a:r>
             <a:pPr indent="0" marL="0">
               <a:spcAft>
@@ -11203,109 +11190,7 @@
                   <a:schemeClr val="tx1"/>
                 </a:solidFill>
               </a:rPr>
-              <a:t>, v. 9, n. 2, p. 137-163, 2001.</a:t>
-            </a:r>
-            <a:endParaRPr lang="en-US" sz="1100" dirty="0"/>
-          </a:p>
-          <a:p>
-            <a:pPr indent="0" marL="0">
-              <a:spcAft>
-                <a:spcPts val="400"/>
-              </a:spcAft>
-              <a:buNone/>
-            </a:pPr>
-            <a:pPr indent="0" marL="0">
-              <a:spcAft>
-                <a:spcPts val="400"/>
-              </a:spcAft>
-              <a:buNone/>
-            </a:pPr>
-            <a:r>
-              <a:rPr lang="en-US" sz="1100" dirty="0">
-                <a:solidFill>
-                  <a:schemeClr val="tx1"/>
-                </a:solidFill>
-              </a:rPr>
-              <a:t>LANDIS, J. R.; KOCH, G. G. The measurement of observer agreement for categorical data. </a:t>
-            </a:r>
-            <a:pPr indent="0" marL="0">
-              <a:spcAft>
-                <a:spcPts val="400"/>
-              </a:spcAft>
-              <a:buNone/>
-            </a:pPr>
-            <a:r>
-              <a:rPr lang="en-US" sz="1100" b="1" dirty="0">
-                <a:solidFill>
-                  <a:schemeClr val="tx1"/>
-                </a:solidFill>
-              </a:rPr>
-              <a:t>Biometrics</a:t>
-            </a:r>
-            <a:pPr indent="0" marL="0">
-              <a:spcAft>
-                <a:spcPts val="400"/>
-              </a:spcAft>
-              <a:buNone/>
-            </a:pPr>
-            <a:r>
-              <a:rPr lang="en-US" sz="1100" dirty="0">
-                <a:solidFill>
-                  <a:schemeClr val="tx1"/>
-                </a:solidFill>
-              </a:rPr>
-              <a:t>, v. 33, n. 1, p. 159-174, 1977.</a:t>
-            </a:r>
-            <a:endParaRPr lang="en-US" sz="1100" dirty="0"/>
-          </a:p>
-          <a:p>
-            <a:pPr indent="0" marL="0">
-              <a:spcAft>
-                <a:spcPts val="400"/>
-              </a:spcAft>
-              <a:buNone/>
-            </a:pPr>
-            <a:pPr indent="0" marL="0">
-              <a:spcAft>
-                <a:spcPts val="400"/>
-              </a:spcAft>
-              <a:buNone/>
-            </a:pPr>
-            <a:r>
-              <a:rPr lang="en-US" sz="1100" dirty="0">
-                <a:solidFill>
-                  <a:schemeClr val="tx1"/>
-                </a:solidFill>
-              </a:rPr>
-              <a:t>NOSEK, B. A. et al. The preregistration revolution. </a:t>
-            </a:r>
-            <a:pPr indent="0" marL="0">
-              <a:spcAft>
-                <a:spcPts val="400"/>
-              </a:spcAft>
-              <a:buNone/>
-            </a:pPr>
-            <a:r>
-              <a:rPr lang="en-US" sz="1100" b="1" dirty="0">
-                <a:solidFill>
-                  <a:schemeClr val="tx1"/>
-                </a:solidFill>
-              </a:rPr>
-              <a:t>Proceedings of the National Academy of Sciences</a:t>
-            </a:r>
-            <a:pPr indent="0" marL="0">
-              <a:spcAft>
-                <a:spcPts val="400"/>
-              </a:spcAft>
-              <a:buNone/>
-            </a:pPr>
-            <a:r>
-              <a:rPr lang="en-US" sz="1100" dirty="0">
-                <a:solidFill>
-                  <a:schemeClr val="tx1"/>
-                </a:solidFill>
-              </a:rPr>
-              <a:t>, v. 115, n. 11, p. 2600-2606, 2018. DOI: 10.1073/pnas.1708274114.</a:t>
+              <a:t>, v. 47, p. 663-685, 1952.</a:t>
             </a:r>
             <a:pPr indent="0" marL="0">
               <a:spcAft>
@@ -11461,7 +11346,7 @@
                   <a:schemeClr val="tx1"/>
                 </a:solidFill>
               </a:rPr>
-              <a:t>OLOFSSON, P. et al. Good practices for estimating area and assessing accuracy of land change. </a:t>
+              <a:t>KAUFMAN, S. et al. Leakage in data mining: formulation, detection, and avoidance. </a:t>
             </a:r>
             <a:pPr indent="0" marL="0">
               <a:spcAft>
@@ -11475,7 +11360,7 @@
                   <a:schemeClr val="tx1"/>
                 </a:solidFill>
               </a:rPr>
-              <a:t>Remote Sensing of Environment</a:t>
+              <a:t>ACM Transactions on Knowledge Discovery from Data</a:t>
             </a:r>
             <a:pPr indent="0" marL="0">
               <a:spcAft>
@@ -11489,7 +11374,7 @@
                   <a:schemeClr val="tx1"/>
                 </a:solidFill>
               </a:rPr>
-              <a:t>, v. 148, p. 42-57, 2014.</a:t>
+              <a:t>, v. 6, n. 4, art. 15, 2012.</a:t>
             </a:r>
             <a:endParaRPr lang="en-US" sz="1100" dirty="0"/>
           </a:p>
@@ -11512,7 +11397,7 @@
                   <a:schemeClr val="tx1"/>
                 </a:solidFill>
               </a:rPr>
-              <a:t>PLOTON, P. et al. Spatial validation reveals poor predictive performance of large-scale ecological mapping models. </a:t>
+              <a:t>KING, G.; ZENG, L. Logistic regression in rare events data. </a:t>
             </a:r>
             <a:pPr indent="0" marL="0">
               <a:spcAft>
@@ -11526,7 +11411,7 @@
                   <a:schemeClr val="tx1"/>
                 </a:solidFill>
               </a:rPr>
-              <a:t>Nature Communications</a:t>
+              <a:t>Political Analysis</a:t>
             </a:r>
             <a:pPr indent="0" marL="0">
               <a:spcAft>
@@ -11540,7 +11425,7 @@
                   <a:schemeClr val="tx1"/>
                 </a:solidFill>
               </a:rPr>
-              <a:t>, v. 11, 2020. DOI: 10.1038/s41467-020-18321-y.</a:t>
+              <a:t>, v. 9, n. 2, p. 137-163, 2001.</a:t>
             </a:r>
             <a:endParaRPr lang="en-US" sz="1100" dirty="0"/>
           </a:p>
@@ -11563,7 +11448,7 @@
                   <a:schemeClr val="tx1"/>
                 </a:solidFill>
               </a:rPr>
-              <a:t>RENARD, K. G. et al. </a:t>
+              <a:t>LANDIS, J. R.; KOCH, G. G. The measurement of observer agreement for categorical data. </a:t>
             </a:r>
             <a:pPr indent="0" marL="0">
               <a:spcAft>
@@ -11577,7 +11462,7 @@
                   <a:schemeClr val="tx1"/>
                 </a:solidFill>
               </a:rPr>
-              <a:t>Predicting soil erosion by water</a:t>
+              <a:t>Biometrics</a:t>
             </a:r>
             <a:pPr indent="0" marL="0">
               <a:spcAft>
@@ -11591,7 +11476,7 @@
                   <a:schemeClr val="tx1"/>
                 </a:solidFill>
               </a:rPr>
-              <a:t>: a guide to conservation planning with the Revised Universal Soil Loss Equation (RUSLE). Washington, DC: USDA, 1997. 404 p. (Agriculture Handbook, 703).</a:t>
+              <a:t>, v. 33, n. 1, p. 159-174, 1977.</a:t>
             </a:r>
             <a:endParaRPr lang="en-US" sz="1100" dirty="0"/>
           </a:p>
@@ -11614,7 +11499,7 @@
                   <a:schemeClr val="tx1"/>
                 </a:solidFill>
               </a:rPr>
-              <a:t>RILEY, R. D. et al. Calculating the sample size required for developing a clinical prediction model. </a:t>
+              <a:t>NOSEK, B. A. et al. The preregistration revolution. </a:t>
             </a:r>
             <a:pPr indent="0" marL="0">
               <a:spcAft>
@@ -11628,7 +11513,7 @@
                   <a:schemeClr val="tx1"/>
                 </a:solidFill>
               </a:rPr>
-              <a:t>BMJ</a:t>
+              <a:t>Proceedings of the National Academy of Sciences</a:t>
             </a:r>
             <a:pPr indent="0" marL="0">
               <a:spcAft>
@@ -11642,7 +11527,7 @@
                   <a:schemeClr val="tx1"/>
                 </a:solidFill>
               </a:rPr>
-              <a:t>, v. 368, art. m441, 2020. DOI: 10.1136/bmj.m441.</a:t>
+              <a:t>, v. 115, n. 11, p. 2600-2606, 2018. DOI: 10.1073/pnas.1708274114.</a:t>
             </a:r>
             <a:endParaRPr lang="en-US" sz="1100" dirty="0"/>
           </a:p>
@@ -11665,7 +11550,7 @@
                   <a:schemeClr val="tx1"/>
                 </a:solidFill>
               </a:rPr>
-              <a:t>ROBERTS, D. R. et al. Cross-validation strategies for data with temporal, spatial, hierarchical, or phylogenetic structure. </a:t>
+              <a:t>OLOFSSON, P. et al. Good practices for estimating area and assessing accuracy of land change. </a:t>
             </a:r>
             <a:pPr indent="0" marL="0">
               <a:spcAft>
@@ -11679,7 +11564,7 @@
                   <a:schemeClr val="tx1"/>
                 </a:solidFill>
               </a:rPr>
-              <a:t>Ecography</a:t>
+              <a:t>Remote Sensing of Environment</a:t>
             </a:r>
             <a:pPr indent="0" marL="0">
               <a:spcAft>
@@ -11693,7 +11578,7 @@
                   <a:schemeClr val="tx1"/>
                 </a:solidFill>
               </a:rPr>
-              <a:t>, v. 40, n. 8, p. 913-929, 2017. DOI: 10.1111/ecog.02881.</a:t>
+              <a:t>, v. 148, p. 42-57, 2014.</a:t>
             </a:r>
             <a:endParaRPr lang="en-US" sz="1100" dirty="0"/>
           </a:p>
@@ -11716,7 +11601,7 @@
                   <a:schemeClr val="tx1"/>
                 </a:solidFill>
               </a:rPr>
-              <a:t>SPEARMAN, C. The proof and measurement of association between two things. </a:t>
+              <a:t>PLOTON, P. et al. Spatial validation reveals poor predictive performance of large-scale ecological mapping models. </a:t>
             </a:r>
             <a:pPr indent="0" marL="0">
               <a:spcAft>
@@ -11730,7 +11615,7 @@
                   <a:schemeClr val="tx1"/>
                 </a:solidFill>
               </a:rPr>
-              <a:t>The American Journal of Psychology</a:t>
+              <a:t>Nature Communications</a:t>
             </a:r>
             <a:pPr indent="0" marL="0">
               <a:spcAft>
@@ -11744,7 +11629,7 @@
                   <a:schemeClr val="tx1"/>
                 </a:solidFill>
               </a:rPr>
-              <a:t>, v. 15, n. 1, p. 72-101, 1904.</a:t>
+              <a:t>, v. 11, 2020. DOI: 10.1038/s41467-020-18321-y.</a:t>
             </a:r>
             <a:endParaRPr lang="en-US" sz="1100" dirty="0"/>
           </a:p>
@@ -11767,7 +11652,7 @@
                   <a:schemeClr val="tx1"/>
                 </a:solidFill>
               </a:rPr>
-              <a:t>VAN DER PLOEG, T.; AUSTIN, P. C.; STEYERBERG, E. W. Modern modelling techniques are data hungry: a simulation study for predicting dichotomous endpoints. </a:t>
+              <a:t>RENARD, K. G. et al. </a:t>
             </a:r>
             <a:pPr indent="0" marL="0">
               <a:spcAft>
@@ -11781,7 +11666,7 @@
                   <a:schemeClr val="tx1"/>
                 </a:solidFill>
               </a:rPr>
-              <a:t>BMC Medical Research Methodology</a:t>
+              <a:t>Predicting soil erosion by water</a:t>
             </a:r>
             <a:pPr indent="0" marL="0">
               <a:spcAft>
@@ -11795,7 +11680,7 @@
                   <a:schemeClr val="tx1"/>
                 </a:solidFill>
               </a:rPr>
-              <a:t>, v. 14, art. 137, 2014. DOI: 10.1186/1471-2288-14-137.</a:t>
+              <a:t>: a guide to conservation planning with the Revised Universal Soil Loss Equation (RUSLE). Washington, DC: USDA, 1997. 404 p. (Agriculture Handbook, 703).</a:t>
             </a:r>
             <a:endParaRPr lang="en-US" sz="1100" dirty="0"/>
           </a:p>
@@ -11818,7 +11703,7 @@
                   <a:schemeClr val="tx1"/>
                 </a:solidFill>
               </a:rPr>
-              <a:t>WALTRICK, P. C. et al. Estimativa da erosividade de chuvas no estado do Paraná pelo método da pluviometria: atualização com dados de 1986 a 2008. </a:t>
+              <a:t>RILEY, R. D. et al. Calculating the sample size required for developing a clinical prediction model. </a:t>
             </a:r>
             <a:pPr indent="0" marL="0">
               <a:spcAft>
@@ -11832,7 +11717,7 @@
                   <a:schemeClr val="tx1"/>
                 </a:solidFill>
               </a:rPr>
-              <a:t>Revista Brasileira de Ciência do Solo</a:t>
+              <a:t>BMJ</a:t>
             </a:r>
             <a:pPr indent="0" marL="0">
               <a:spcAft>
@@ -11846,58 +11731,7 @@
                   <a:schemeClr val="tx1"/>
                 </a:solidFill>
               </a:rPr>
-              <a:t>, v. 39, n. 1, p. 256-267, 2015. DOI: 10.1590/01000683rbcs20150147.</a:t>
-            </a:r>
-            <a:endParaRPr lang="en-US" sz="1100" dirty="0"/>
-          </a:p>
-          <a:p>
-            <a:pPr indent="0" marL="0">
-              <a:spcAft>
-                <a:spcPts val="400"/>
-              </a:spcAft>
-              <a:buNone/>
-            </a:pPr>
-            <a:pPr indent="0" marL="0">
-              <a:spcAft>
-                <a:spcPts val="400"/>
-              </a:spcAft>
-              <a:buNone/>
-            </a:pPr>
-            <a:r>
-              <a:rPr lang="en-US" sz="1100" dirty="0">
-                <a:solidFill>
-                  <a:schemeClr val="tx1"/>
-                </a:solidFill>
-              </a:rPr>
-              <a:t>WISCHMEIER, W. H.; SMITH, D. D. </a:t>
-            </a:r>
-            <a:pPr indent="0" marL="0">
-              <a:spcAft>
-                <a:spcPts val="400"/>
-              </a:spcAft>
-              <a:buNone/>
-            </a:pPr>
-            <a:r>
-              <a:rPr lang="en-US" sz="1100" b="1" dirty="0">
-                <a:solidFill>
-                  <a:schemeClr val="tx1"/>
-                </a:solidFill>
-              </a:rPr>
-              <a:t>Predicting rainfall erosion losses</a:t>
-            </a:r>
-            <a:pPr indent="0" marL="0">
-              <a:spcAft>
-                <a:spcPts val="400"/>
-              </a:spcAft>
-              <a:buNone/>
-            </a:pPr>
-            <a:r>
-              <a:rPr lang="en-US" sz="1100" dirty="0">
-                <a:solidFill>
-                  <a:schemeClr val="tx1"/>
-                </a:solidFill>
-              </a:rPr>
-              <a:t>: a guide to conservation planning. Washington, DC: USDA, 1978. (Agriculture Handbook, 537).</a:t>
+              <a:t>, v. 368, art. m441, 2020. DOI: 10.1136/bmj.m441.</a:t>
             </a:r>
             <a:pPr indent="0" marL="0">
               <a:spcAft>
@@ -11949,6 +11783,445 @@
             <a:fld id="{F7021451-1387-4CA6-816F-3879F97B5CBC}" type="slidenum">
               <a:rPr b="0" lang="en-US"/>
               <a:t>25</a:t>
+            </a:fld>
+            <a:endParaRPr lang="en-US"/>
+          </a:p>
+        </p:txBody>
+      </p:sp>
+    </p:spTree>
+  </p:cSld>
+  <p:clrMapOvr>
+    <a:masterClrMapping/>
+  </p:clrMapOvr>
+</p:sld>
+</file>
+
+<file path=ppt/slides/slide26.xml><?xml version="1.0" encoding="utf-8"?>
+<p:sld xmlns:a="http://schemas.openxmlformats.org/drawingml/2006/main" xmlns:r="http://schemas.openxmlformats.org/officeDocument/2006/relationships" xmlns:p="http://schemas.openxmlformats.org/presentationml/2006/main">
+  <p:cSld name="Slide 26">
+    <p:spTree>
+      <p:nvGrpSpPr>
+        <p:cNvPr id="1" name=""/>
+        <p:cNvGrpSpPr/>
+        <p:nvPr/>
+      </p:nvGrpSpPr>
+      <p:grpSpPr>
+        <a:xfrm>
+          <a:off x="0" y="0"/>
+          <a:ext cx="0" cy="0"/>
+          <a:chOff x="0" y="0"/>
+          <a:chExt cx="0" cy="0"/>
+        </a:xfrm>
+      </p:grpSpPr>
+      <p:sp>
+        <p:nvSpPr>
+          <p:cNvPr id="2" name="Text 1"/>
+          <p:cNvSpPr/>
+          <p:nvPr>
+            <p:ph idx="101" type="title" hasCustomPrompt="1"/>
+          </p:nvPr>
+        </p:nvSpPr>
+        <p:spPr>
+          <a:xfrm>
+            <a:off x="457200" y="274320"/>
+            <a:ext cx="8229600" cy="731520"/>
+          </a:xfrm>
+          <a:prstGeom prst="rect">
+            <a:avLst/>
+          </a:prstGeom>
+          <a:noFill/>
+          <a:ln/>
+        </p:spPr>
+        <p:txBody>
+          <a:bodyPr wrap="square" lIns="0" tIns="0" rIns="0" bIns="0" rtlCol="0" anchor="ctr"/>
+          <a:lstStyle/>
+          <a:p>
+            <a:pPr algn="l" indent="0" marL="0">
+              <a:buNone/>
+            </a:pPr>
+            <a:r>
+              <a:rPr lang="en-US" sz="2600" b="1" dirty="0">
+                <a:solidFill>
+                  <a:schemeClr val="tx1"/>
+                </a:solidFill>
+                <a:latin typeface="Cambria" pitchFamily="34" charset="0"/>
+                <a:ea typeface="Cambria" pitchFamily="34" charset="-122"/>
+                <a:cs typeface="Cambria" pitchFamily="34" charset="-120"/>
+              </a:rPr>
+              <a:t>Referências (ABNT NBR 6023) — 4/3</a:t>
+            </a:r>
+            <a:endParaRPr lang="en-US" sz="2600" dirty="0"/>
+          </a:p>
+        </p:txBody>
+      </p:sp>
+      <p:sp>
+        <p:nvSpPr>
+          <p:cNvPr id="4" name="Text 1"/>
+          <p:cNvSpPr txBox="1"/>
+          <p:nvPr/>
+        </p:nvSpPr>
+        <p:spPr>
+          <a:xfrm>
+            <a:off x="457200" y="1051560"/>
+            <a:ext cx="8229600" cy="3703320"/>
+          </a:xfrm>
+          <a:prstGeom prst="rect">
+            <a:avLst/>
+          </a:prstGeom>
+          <a:noFill/>
+          <a:ln/>
+        </p:spPr>
+        <p:txBody>
+          <a:bodyPr wrap="square" lIns="0" tIns="0" rIns="0" bIns="0" rtlCol="0" anchor="t"/>
+          <a:lstStyle/>
+          <a:p>
+            <a:pPr indent="0" marL="0">
+              <a:spcAft>
+                <a:spcPts val="400"/>
+              </a:spcAft>
+              <a:buNone/>
+            </a:pPr>
+            <a:r>
+              <a:rPr lang="en-US" sz="1100" dirty="0">
+                <a:solidFill>
+                  <a:schemeClr val="tx1"/>
+                </a:solidFill>
+              </a:rPr>
+              <a:t>ROBERTS, D. R. et al. Cross-validation strategies for data with temporal, spatial, hierarchical, or phylogenetic structure. </a:t>
+            </a:r>
+            <a:pPr indent="0" marL="0">
+              <a:spcAft>
+                <a:spcPts val="400"/>
+              </a:spcAft>
+              <a:buNone/>
+            </a:pPr>
+            <a:r>
+              <a:rPr lang="en-US" sz="1100" b="1" dirty="0">
+                <a:solidFill>
+                  <a:schemeClr val="tx1"/>
+                </a:solidFill>
+              </a:rPr>
+              <a:t>Ecography</a:t>
+            </a:r>
+            <a:pPr indent="0" marL="0">
+              <a:spcAft>
+                <a:spcPts val="400"/>
+              </a:spcAft>
+              <a:buNone/>
+            </a:pPr>
+            <a:r>
+              <a:rPr lang="en-US" sz="1100" dirty="0">
+                <a:solidFill>
+                  <a:schemeClr val="tx1"/>
+                </a:solidFill>
+              </a:rPr>
+              <a:t>, v. 40, n. 8, p. 913-929, 2017. DOI: 10.1111/ecog.02881.</a:t>
+            </a:r>
+            <a:endParaRPr lang="en-US" sz="1100" dirty="0"/>
+          </a:p>
+          <a:p>
+            <a:pPr indent="0" marL="0">
+              <a:spcAft>
+                <a:spcPts val="400"/>
+              </a:spcAft>
+              <a:buNone/>
+            </a:pPr>
+            <a:pPr indent="0" marL="0">
+              <a:spcAft>
+                <a:spcPts val="400"/>
+              </a:spcAft>
+              <a:buNone/>
+            </a:pPr>
+            <a:r>
+              <a:rPr lang="en-US" sz="1100" dirty="0">
+                <a:solidFill>
+                  <a:schemeClr val="tx1"/>
+                </a:solidFill>
+              </a:rPr>
+              <a:t>SPEARMAN, C. The proof and measurement of association between two things. </a:t>
+            </a:r>
+            <a:pPr indent="0" marL="0">
+              <a:spcAft>
+                <a:spcPts val="400"/>
+              </a:spcAft>
+              <a:buNone/>
+            </a:pPr>
+            <a:r>
+              <a:rPr lang="en-US" sz="1100" b="1" dirty="0">
+                <a:solidFill>
+                  <a:schemeClr val="tx1"/>
+                </a:solidFill>
+              </a:rPr>
+              <a:t>The American Journal of Psychology</a:t>
+            </a:r>
+            <a:pPr indent="0" marL="0">
+              <a:spcAft>
+                <a:spcPts val="400"/>
+              </a:spcAft>
+              <a:buNone/>
+            </a:pPr>
+            <a:r>
+              <a:rPr lang="en-US" sz="1100" dirty="0">
+                <a:solidFill>
+                  <a:schemeClr val="tx1"/>
+                </a:solidFill>
+              </a:rPr>
+              <a:t>, v. 15, n. 1, p. 72-101, 1904.</a:t>
+            </a:r>
+            <a:endParaRPr lang="en-US" sz="1100" dirty="0"/>
+          </a:p>
+          <a:p>
+            <a:pPr indent="0" marL="0">
+              <a:spcAft>
+                <a:spcPts val="400"/>
+              </a:spcAft>
+              <a:buNone/>
+            </a:pPr>
+            <a:pPr indent="0" marL="0">
+              <a:spcAft>
+                <a:spcPts val="400"/>
+              </a:spcAft>
+              <a:buNone/>
+            </a:pPr>
+            <a:r>
+              <a:rPr lang="en-US" sz="1100" dirty="0">
+                <a:solidFill>
+                  <a:schemeClr val="tx1"/>
+                </a:solidFill>
+              </a:rPr>
+              <a:t>VAN DER PLOEG, T.; AUSTIN, P. C.; STEYERBERG, E. W. Modern modelling techniques are data hungry: a simulation study for predicting dichotomous endpoints. </a:t>
+            </a:r>
+            <a:pPr indent="0" marL="0">
+              <a:spcAft>
+                <a:spcPts val="400"/>
+              </a:spcAft>
+              <a:buNone/>
+            </a:pPr>
+            <a:r>
+              <a:rPr lang="en-US" sz="1100" b="1" dirty="0">
+                <a:solidFill>
+                  <a:schemeClr val="tx1"/>
+                </a:solidFill>
+              </a:rPr>
+              <a:t>BMC Medical Research Methodology</a:t>
+            </a:r>
+            <a:pPr indent="0" marL="0">
+              <a:spcAft>
+                <a:spcPts val="400"/>
+              </a:spcAft>
+              <a:buNone/>
+            </a:pPr>
+            <a:r>
+              <a:rPr lang="en-US" sz="1100" dirty="0">
+                <a:solidFill>
+                  <a:schemeClr val="tx1"/>
+                </a:solidFill>
+              </a:rPr>
+              <a:t>, v. 14, art. 137, 2014. DOI: 10.1186/1471-2288-14-137.</a:t>
+            </a:r>
+            <a:endParaRPr lang="en-US" sz="1100" dirty="0"/>
+          </a:p>
+          <a:p>
+            <a:pPr indent="0" marL="0">
+              <a:spcAft>
+                <a:spcPts val="400"/>
+              </a:spcAft>
+              <a:buNone/>
+            </a:pPr>
+            <a:pPr indent="0" marL="0">
+              <a:spcAft>
+                <a:spcPts val="400"/>
+              </a:spcAft>
+              <a:buNone/>
+            </a:pPr>
+            <a:r>
+              <a:rPr lang="en-US" sz="1100" dirty="0">
+                <a:solidFill>
+                  <a:schemeClr val="tx1"/>
+                </a:solidFill>
+              </a:rPr>
+              <a:t>WALTRICK, P. C. </a:t>
+            </a:r>
+            <a:pPr indent="0" marL="0">
+              <a:spcAft>
+                <a:spcPts val="400"/>
+              </a:spcAft>
+              <a:buNone/>
+            </a:pPr>
+            <a:r>
+              <a:rPr lang="en-US" sz="1100" b="1" dirty="0">
+                <a:solidFill>
+                  <a:schemeClr val="tx1"/>
+                </a:solidFill>
+              </a:rPr>
+              <a:t>Erosividade de chuvas no Paraná</a:t>
+            </a:r>
+            <a:pPr indent="0" marL="0">
+              <a:spcAft>
+                <a:spcPts val="400"/>
+              </a:spcAft>
+              <a:buNone/>
+            </a:pPr>
+            <a:r>
+              <a:rPr lang="en-US" sz="1100" dirty="0">
+                <a:solidFill>
+                  <a:schemeClr val="tx1"/>
+                </a:solidFill>
+              </a:rPr>
+              <a:t>: atualização, influência do "El Niño" e "La Niña" e estimativa para cenários climáticos futuros. 2010. 107 f. Dissertação (Mestrado em Ciência do Solo) – Setor de Ciências Agrárias, Universidade Federal do Paraná, Curitiba, 2010.</a:t>
+            </a:r>
+            <a:endParaRPr lang="en-US" sz="1100" dirty="0"/>
+          </a:p>
+          <a:p>
+            <a:pPr indent="0" marL="0">
+              <a:spcAft>
+                <a:spcPts val="400"/>
+              </a:spcAft>
+              <a:buNone/>
+            </a:pPr>
+            <a:pPr indent="0" marL="0">
+              <a:spcAft>
+                <a:spcPts val="400"/>
+              </a:spcAft>
+              <a:buNone/>
+            </a:pPr>
+            <a:r>
+              <a:rPr lang="en-US" sz="1100" dirty="0">
+                <a:solidFill>
+                  <a:schemeClr val="tx1"/>
+                </a:solidFill>
+              </a:rPr>
+              <a:t>WALTRICK, P. C. et al. Estimativa da erosividade de chuvas no estado do Paraná pelo método da pluviometria: atualização com dados de 1986 a 2008. </a:t>
+            </a:r>
+            <a:pPr indent="0" marL="0">
+              <a:spcAft>
+                <a:spcPts val="400"/>
+              </a:spcAft>
+              <a:buNone/>
+            </a:pPr>
+            <a:r>
+              <a:rPr lang="en-US" sz="1100" b="1" dirty="0">
+                <a:solidFill>
+                  <a:schemeClr val="tx1"/>
+                </a:solidFill>
+              </a:rPr>
+              <a:t>Revista Brasileira de Ciência do Solo</a:t>
+            </a:r>
+            <a:pPr indent="0" marL="0">
+              <a:spcAft>
+                <a:spcPts val="400"/>
+              </a:spcAft>
+              <a:buNone/>
+            </a:pPr>
+            <a:r>
+              <a:rPr lang="en-US" sz="1100" dirty="0">
+                <a:solidFill>
+                  <a:schemeClr val="tx1"/>
+                </a:solidFill>
+              </a:rPr>
+              <a:t>, v. 39, n. 1, p. 256-267, 2015. DOI: 10.1590/01000683rbcs20150147.</a:t>
+            </a:r>
+            <a:endParaRPr lang="en-US" sz="1100" dirty="0"/>
+          </a:p>
+          <a:p>
+            <a:pPr indent="0" marL="0">
+              <a:spcAft>
+                <a:spcPts val="400"/>
+              </a:spcAft>
+              <a:buNone/>
+            </a:pPr>
+            <a:pPr indent="0" marL="0">
+              <a:spcAft>
+                <a:spcPts val="400"/>
+              </a:spcAft>
+              <a:buNone/>
+            </a:pPr>
+            <a:r>
+              <a:rPr lang="en-US" sz="1100" dirty="0">
+                <a:solidFill>
+                  <a:schemeClr val="tx1"/>
+                </a:solidFill>
+              </a:rPr>
+              <a:t>WISCHMEIER, W. H.; SMITH, D. D. </a:t>
+            </a:r>
+            <a:pPr indent="0" marL="0">
+              <a:spcAft>
+                <a:spcPts val="400"/>
+              </a:spcAft>
+              <a:buNone/>
+            </a:pPr>
+            <a:r>
+              <a:rPr lang="en-US" sz="1100" b="1" dirty="0">
+                <a:solidFill>
+                  <a:schemeClr val="tx1"/>
+                </a:solidFill>
+              </a:rPr>
+              <a:t>Predicting rainfall erosion losses</a:t>
+            </a:r>
+            <a:pPr indent="0" marL="0">
+              <a:spcAft>
+                <a:spcPts val="400"/>
+              </a:spcAft>
+              <a:buNone/>
+            </a:pPr>
+            <a:r>
+              <a:rPr lang="en-US" sz="1100" dirty="0">
+                <a:solidFill>
+                  <a:schemeClr val="tx1"/>
+                </a:solidFill>
+              </a:rPr>
+              <a:t>: a guide to conservation planning. Washington, DC: USDA, 1978. (Agriculture Handbook, 537).</a:t>
+            </a:r>
+            <a:pPr indent="0" marL="0">
+              <a:spcAft>
+                <a:spcPts val="400"/>
+              </a:spcAft>
+              <a:buNone/>
+            </a:pPr>
+            <a:endParaRPr lang="en-US" sz="1100" dirty="0"/>
+          </a:p>
+        </p:txBody>
+      </p:sp>
+      <p:sp>
+        <p:nvSpPr>
+          <p:cNvPr id="25" name="Slide Number Placeholder 0"/>
+          <p:cNvSpPr>
+            <a:spLocks noGrp="1"/>
+          </p:cNvSpPr>
+          <p:nvPr>
+            <p:ph type="sldNum" sz="quarter" idx="4294967295"/>
+          </p:nvPr>
+        </p:nvSpPr>
+        <p:spPr>
+          <a:xfrm>
+            <a:off x="8229600" y="4828032"/>
+            <a:ext cx="457200" cy="228600"/>
+          </a:xfrm>
+          <a:prstGeom prst="rect">
+            <a:avLst/>
+          </a:prstGeom>
+          <a:extLst>
+            <a:ext uri="{C572A759-6A51-4108-AA02-DFA0A04FC94B}">
+              <ma14:wrappingTextBoxFlag xmlns:ma14="http://schemas.microsoft.com/office/mac/drawingml/2011/main" val="0"/>
+            </a:ext>
+          </a:extLst>
+        </p:spPr>
+        <p:txBody>
+          <a:bodyPr/>
+          <a:lstStyle>
+            <a:lvl1pPr>
+              <a:defRPr sz="1000">
+                <a:solidFill>
+                  <a:schemeClr val="tx2"/>
+                </a:solidFill>
+              </a:defRPr>
+            </a:lvl1pPr>
+          </a:lstStyle>
+          <a:p>
+            <a:pPr algn="r"/>
+            <a:fld id="{F7021451-1387-4CA6-816F-3879F97B5CBC}" type="slidenum">
+              <a:rPr b="0" lang="en-US"/>
+              <a:t>26</a:t>
             </a:fld>
             <a:endParaRPr lang="en-US"/>
           </a:p>
@@ -16449,7 +16722,7 @@
                   <a:schemeClr val="tx2"/>
                 </a:solidFill>
               </a:rPr>
-              <a:t>C: (DURIGON et al., 2014); LS: (DESMET; GOVERS, 1996); A: (RENARD et al., 1997). R: sucedâneo regional do EI30 (D13); fator de unidade 9,81 reproduzido em pluviômetros do IAT (origem física a confirmar).</a:t>
+              <a:t>C: (DURIGON et al., 2014); LS: (DESMET; GOVERS, 1996); A: (RENARD et al., 1997). R: sucedâneo regional do EI30 (D13); fator de unidade 9,81 (conversão para o SI; (WALTRICK, 2010)), reproduzido em pluviômetros do IAT.</a:t>
             </a:r>
             <a:endParaRPr lang="en-US" sz="1000" dirty="0"/>
           </a:p>

</xml_diff>